<commit_message>
Deck: point repo link and QR at the renamed stallwart repository
</commit_message>
<xml_diff>
--- a/Submission Template _ AI Builder Cup.pptx
+++ b/Submission Template _ AI Builder Cup.pptx
@@ -14843,14 +14843,14 @@
       </p:sp>
       <p:pic>
         <p:nvPicPr>
-          <p:cNvPr id="197" name="Picture 196" descr="image.png"/>
+          <p:cNvPr id="197" name="Picture 196" descr="qr-repo.png"/>
           <p:cNvPicPr>
             <a:picLocks noChangeAspect="1"/>
           </p:cNvPicPr>
           <p:nvPr/>
         </p:nvPicPr>
         <p:blipFill>
-          <a:blip r:embed="rId7"/>
+          <a:blip r:embed="rId9"/>
           <a:stretch>
             <a:fillRect/>
           </a:stretch>
@@ -14938,7 +14938,7 @@
                 </a:solidFill>
                 <a:latin typeface="Segoe UI"/>
               </a:rPr>
-              <a:t>github.com/OWAIS285/honey_trap</a:t>
+              <a:t>github.com/OWAIS285/stallwart</a:t>
             </a:r>
           </a:p>
         </p:txBody>

</xml_diff>